<commit_message>
update geebiophys version in figure
</commit_message>
<xml_diff>
--- a/revision-figures/figure-1/overview_diagram_v2.pptx
+++ b/revision-figures/figure-1/overview_diagram_v2.pptx
@@ -197,7 +197,7 @@
           <a:p>
             <a:fld id="{A6F036F8-F71A-AB44-B1DB-CD13AAD1D3DB}" type="datetimeFigureOut">
               <a:rPr lang="en-CH" smtClean="0"/>
-              <a:t>17.09.2026</a:t>
+              <a:t>18.09.2026</a:t>
             </a:fld>
             <a:endParaRPr lang="en-CH"/>
           </a:p>
@@ -722,7 +722,7 @@
           <a:p>
             <a:fld id="{C1AF0D33-9AC4-2449-ABB5-01686A3840D3}" type="datetimeFigureOut">
               <a:rPr lang="en-CH" smtClean="0"/>
-              <a:t>17.09.2026</a:t>
+              <a:t>18.09.2026</a:t>
             </a:fld>
             <a:endParaRPr lang="en-CH"/>
           </a:p>
@@ -922,7 +922,7 @@
           <a:p>
             <a:fld id="{C1AF0D33-9AC4-2449-ABB5-01686A3840D3}" type="datetimeFigureOut">
               <a:rPr lang="en-CH" smtClean="0"/>
-              <a:t>17.09.2026</a:t>
+              <a:t>18.09.2026</a:t>
             </a:fld>
             <a:endParaRPr lang="en-CH"/>
           </a:p>
@@ -1132,7 +1132,7 @@
           <a:p>
             <a:fld id="{C1AF0D33-9AC4-2449-ABB5-01686A3840D3}" type="datetimeFigureOut">
               <a:rPr lang="en-CH" smtClean="0"/>
-              <a:t>17.09.2026</a:t>
+              <a:t>18.09.2026</a:t>
             </a:fld>
             <a:endParaRPr lang="en-CH"/>
           </a:p>
@@ -1332,7 +1332,7 @@
           <a:p>
             <a:fld id="{C1AF0D33-9AC4-2449-ABB5-01686A3840D3}" type="datetimeFigureOut">
               <a:rPr lang="en-CH" smtClean="0"/>
-              <a:t>17.09.2026</a:t>
+              <a:t>18.09.2026</a:t>
             </a:fld>
             <a:endParaRPr lang="en-CH"/>
           </a:p>
@@ -1608,7 +1608,7 @@
           <a:p>
             <a:fld id="{C1AF0D33-9AC4-2449-ABB5-01686A3840D3}" type="datetimeFigureOut">
               <a:rPr lang="en-CH" smtClean="0"/>
-              <a:t>17.09.2026</a:t>
+              <a:t>18.09.2026</a:t>
             </a:fld>
             <a:endParaRPr lang="en-CH"/>
           </a:p>
@@ -1876,7 +1876,7 @@
           <a:p>
             <a:fld id="{C1AF0D33-9AC4-2449-ABB5-01686A3840D3}" type="datetimeFigureOut">
               <a:rPr lang="en-CH" smtClean="0"/>
-              <a:t>17.09.2026</a:t>
+              <a:t>18.09.2026</a:t>
             </a:fld>
             <a:endParaRPr lang="en-CH"/>
           </a:p>
@@ -2291,7 +2291,7 @@
           <a:p>
             <a:fld id="{C1AF0D33-9AC4-2449-ABB5-01686A3840D3}" type="datetimeFigureOut">
               <a:rPr lang="en-CH" smtClean="0"/>
-              <a:t>17.09.2026</a:t>
+              <a:t>18.09.2026</a:t>
             </a:fld>
             <a:endParaRPr lang="en-CH"/>
           </a:p>
@@ -2433,7 +2433,7 @@
           <a:p>
             <a:fld id="{C1AF0D33-9AC4-2449-ABB5-01686A3840D3}" type="datetimeFigureOut">
               <a:rPr lang="en-CH" smtClean="0"/>
-              <a:t>17.09.2026</a:t>
+              <a:t>18.09.2026</a:t>
             </a:fld>
             <a:endParaRPr lang="en-CH"/>
           </a:p>
@@ -2546,7 +2546,7 @@
           <a:p>
             <a:fld id="{C1AF0D33-9AC4-2449-ABB5-01686A3840D3}" type="datetimeFigureOut">
               <a:rPr lang="en-CH" smtClean="0"/>
-              <a:t>17.09.2026</a:t>
+              <a:t>18.09.2026</a:t>
             </a:fld>
             <a:endParaRPr lang="en-CH"/>
           </a:p>
@@ -2859,7 +2859,7 @@
           <a:p>
             <a:fld id="{C1AF0D33-9AC4-2449-ABB5-01686A3840D3}" type="datetimeFigureOut">
               <a:rPr lang="en-CH" smtClean="0"/>
-              <a:t>17.09.2026</a:t>
+              <a:t>18.09.2026</a:t>
             </a:fld>
             <a:endParaRPr lang="en-CH"/>
           </a:p>
@@ -3148,7 +3148,7 @@
           <a:p>
             <a:fld id="{C1AF0D33-9AC4-2449-ABB5-01686A3840D3}" type="datetimeFigureOut">
               <a:rPr lang="en-CH" smtClean="0"/>
-              <a:t>17.09.2026</a:t>
+              <a:t>18.09.2026</a:t>
             </a:fld>
             <a:endParaRPr lang="en-CH"/>
           </a:p>
@@ -3391,7 +3391,7 @@
           <a:p>
             <a:fld id="{C1AF0D33-9AC4-2449-ABB5-01686A3840D3}" type="datetimeFigureOut">
               <a:rPr lang="en-CH" smtClean="0"/>
-              <a:t>17.09.2026</a:t>
+              <a:t>18.09.2026</a:t>
             </a:fld>
             <a:endParaRPr lang="en-CH"/>
           </a:p>
@@ -16465,91 +16465,6 @@
           </p:style>
         </p:cxnSp>
       </p:grpSp>
-      <p:grpSp>
-        <p:nvGrpSpPr>
-          <p:cNvPr id="273" name="Group 272">
-            <a:extLst>
-              <a:ext uri="{FF2B5EF4-FFF2-40B4-BE49-F238E27FC236}">
-                <a16:creationId xmlns:a16="http://schemas.microsoft.com/office/drawing/2014/main" id="{79F560BF-9ABE-225C-7DF8-4D0AD4EBA4D2}"/>
-              </a:ext>
-            </a:extLst>
-          </p:cNvPr>
-          <p:cNvGrpSpPr>
-            <a:grpSpLocks noChangeAspect="1"/>
-          </p:cNvGrpSpPr>
-          <p:nvPr/>
-        </p:nvGrpSpPr>
-        <p:grpSpPr>
-          <a:xfrm>
-            <a:off x="8270810" y="4764680"/>
-            <a:ext cx="1393696" cy="552607"/>
-            <a:chOff x="4266000" y="2520950"/>
-            <a:chExt cx="3963600" cy="1571585"/>
-          </a:xfrm>
-        </p:grpSpPr>
-        <p:pic>
-          <p:nvPicPr>
-            <p:cNvPr id="269" name="Picture 268">
-              <a:extLst>
-                <a:ext uri="{FF2B5EF4-FFF2-40B4-BE49-F238E27FC236}">
-                  <a16:creationId xmlns:a16="http://schemas.microsoft.com/office/drawing/2014/main" id="{C04D9D59-982C-A5D3-BAA4-DF559EB6F5EA}"/>
-                </a:ext>
-              </a:extLst>
-            </p:cNvPr>
-            <p:cNvPicPr>
-              <a:picLocks noChangeAspect="1"/>
-            </p:cNvPicPr>
-            <p:nvPr/>
-          </p:nvPicPr>
-          <p:blipFill>
-            <a:blip r:embed="rId14"/>
-            <a:srcRect t="59439"/>
-            <a:stretch>
-              <a:fillRect/>
-            </a:stretch>
-          </p:blipFill>
-          <p:spPr>
-            <a:xfrm>
-              <a:off x="4266000" y="3232266"/>
-              <a:ext cx="3962400" cy="860269"/>
-            </a:xfrm>
-            <a:prstGeom prst="rect">
-              <a:avLst/>
-            </a:prstGeom>
-          </p:spPr>
-        </p:pic>
-        <p:pic>
-          <p:nvPicPr>
-            <p:cNvPr id="270" name="Picture 269">
-              <a:extLst>
-                <a:ext uri="{FF2B5EF4-FFF2-40B4-BE49-F238E27FC236}">
-                  <a16:creationId xmlns:a16="http://schemas.microsoft.com/office/drawing/2014/main" id="{6CA542DA-E5F0-1DC2-EAAD-9C9A61BD1474}"/>
-                </a:ext>
-              </a:extLst>
-            </p:cNvPr>
-            <p:cNvPicPr>
-              <a:picLocks noChangeAspect="1"/>
-            </p:cNvPicPr>
-            <p:nvPr/>
-          </p:nvPicPr>
-          <p:blipFill>
-            <a:blip r:embed="rId14"/>
-            <a:srcRect b="65529"/>
-            <a:stretch>
-              <a:fillRect/>
-            </a:stretch>
-          </p:blipFill>
-          <p:spPr>
-            <a:xfrm>
-              <a:off x="4267200" y="2520950"/>
-              <a:ext cx="3962400" cy="731092"/>
-            </a:xfrm>
-            <a:prstGeom prst="rect">
-              <a:avLst/>
-            </a:prstGeom>
-          </p:spPr>
-        </p:pic>
-      </p:grpSp>
       <p:sp>
         <p:nvSpPr>
           <p:cNvPr id="281" name="TextBox 280">
@@ -16854,6 +16769,91 @@
           </a:prstGeom>
         </p:spPr>
       </p:pic>
+      <p:grpSp>
+        <p:nvGrpSpPr>
+          <p:cNvPr id="27" name="Group 26">
+            <a:extLst>
+              <a:ext uri="{FF2B5EF4-FFF2-40B4-BE49-F238E27FC236}">
+                <a16:creationId xmlns:a16="http://schemas.microsoft.com/office/drawing/2014/main" id="{9DE4BA8D-69E9-8203-E415-63E0E6180CAC}"/>
+              </a:ext>
+            </a:extLst>
+          </p:cNvPr>
+          <p:cNvGrpSpPr>
+            <a:grpSpLocks noChangeAspect="1"/>
+          </p:cNvGrpSpPr>
+          <p:nvPr/>
+        </p:nvGrpSpPr>
+        <p:grpSpPr>
+          <a:xfrm>
+            <a:off x="8342784" y="4669841"/>
+            <a:ext cx="1271099" cy="438512"/>
+            <a:chOff x="3852525" y="3005124"/>
+            <a:chExt cx="4762500" cy="1642996"/>
+          </a:xfrm>
+        </p:grpSpPr>
+        <p:pic>
+          <p:nvPicPr>
+            <p:cNvPr id="25" name="Picture 24">
+              <a:extLst>
+                <a:ext uri="{FF2B5EF4-FFF2-40B4-BE49-F238E27FC236}">
+                  <a16:creationId xmlns:a16="http://schemas.microsoft.com/office/drawing/2014/main" id="{D22C165B-E5F1-61B2-BD16-B28161A7736F}"/>
+                </a:ext>
+              </a:extLst>
+            </p:cNvPr>
+            <p:cNvPicPr>
+              <a:picLocks noChangeAspect="1"/>
+            </p:cNvPicPr>
+            <p:nvPr/>
+          </p:nvPicPr>
+          <p:blipFill>
+            <a:blip r:embed="rId14"/>
+            <a:srcRect b="63910"/>
+            <a:stretch>
+              <a:fillRect/>
+            </a:stretch>
+          </p:blipFill>
+          <p:spPr>
+            <a:xfrm>
+              <a:off x="3852525" y="3005124"/>
+              <a:ext cx="4762500" cy="756276"/>
+            </a:xfrm>
+            <a:prstGeom prst="rect">
+              <a:avLst/>
+            </a:prstGeom>
+          </p:spPr>
+        </p:pic>
+        <p:pic>
+          <p:nvPicPr>
+            <p:cNvPr id="26" name="Picture 25">
+              <a:extLst>
+                <a:ext uri="{FF2B5EF4-FFF2-40B4-BE49-F238E27FC236}">
+                  <a16:creationId xmlns:a16="http://schemas.microsoft.com/office/drawing/2014/main" id="{D169DD00-8B74-11B9-9A12-2AF8A6151CC3}"/>
+                </a:ext>
+              </a:extLst>
+            </p:cNvPr>
+            <p:cNvPicPr>
+              <a:picLocks noChangeAspect="1"/>
+            </p:cNvPicPr>
+            <p:nvPr/>
+          </p:nvPicPr>
+          <p:blipFill>
+            <a:blip r:embed="rId14"/>
+            <a:srcRect t="57334"/>
+            <a:stretch>
+              <a:fillRect/>
+            </a:stretch>
+          </p:blipFill>
+          <p:spPr>
+            <a:xfrm>
+              <a:off x="3852525" y="3754061"/>
+              <a:ext cx="4762500" cy="894059"/>
+            </a:xfrm>
+            <a:prstGeom prst="rect">
+              <a:avLst/>
+            </a:prstGeom>
+          </p:spPr>
+        </p:pic>
+      </p:grpSp>
     </p:spTree>
     <p:extLst>
       <p:ext uri="{BB962C8B-B14F-4D97-AF65-F5344CB8AC3E}">

</xml_diff>